<commit_message>
Correct capitalization in the "What to do" section of hw_2.md for consistency. Update binary files for tutorials in week 2 and week 3 to reflect recent changes.
</commit_message>
<xml_diff>
--- a/tutorials/week_2/2.command_line.pptx
+++ b/tutorials/week_2/2.command_line.pptx
@@ -235,7 +235,7 @@
           <a:p>
             <a:fld id="{E8FD0B7A-F5DD-4F40-B4CB-3B2C354B893A}" type="datetimeFigureOut">
               <a:rPr lang="en-US" smtClean="0"/>
-              <a:t>8/5/2025</a:t>
+              <a:t>8/14/2025</a:t>
             </a:fld>
             <a:endParaRPr lang="en-US"/>
           </a:p>
@@ -408,7 +408,7 @@
           <a:p>
             <a:fld id="{E8FD0B7A-F5DD-4F40-B4CB-3B2C354B893A}" type="datetimeFigureOut">
               <a:rPr lang="en-US" smtClean="0"/>
-              <a:t>8/5/2025</a:t>
+              <a:t>8/14/2025</a:t>
             </a:fld>
             <a:endParaRPr lang="en-US"/>
           </a:p>
@@ -591,7 +591,7 @@
           <a:p>
             <a:fld id="{E8FD0B7A-F5DD-4F40-B4CB-3B2C354B893A}" type="datetimeFigureOut">
               <a:rPr lang="en-US" smtClean="0"/>
-              <a:t>8/5/2025</a:t>
+              <a:t>8/14/2025</a:t>
             </a:fld>
             <a:endParaRPr lang="en-US"/>
           </a:p>
@@ -764,7 +764,7 @@
           <a:p>
             <a:fld id="{E8FD0B7A-F5DD-4F40-B4CB-3B2C354B893A}" type="datetimeFigureOut">
               <a:rPr lang="en-US" smtClean="0"/>
-              <a:t>8/5/2025</a:t>
+              <a:t>8/14/2025</a:t>
             </a:fld>
             <a:endParaRPr lang="en-US"/>
           </a:p>
@@ -929,7 +929,7 @@
           <a:p>
             <a:fld id="{E8FD0B7A-F5DD-4F40-B4CB-3B2C354B893A}" type="datetimeFigureOut">
               <a:rPr lang="en-US" smtClean="0"/>
-              <a:t>8/5/2025</a:t>
+              <a:t>8/14/2025</a:t>
             </a:fld>
             <a:endParaRPr lang="en-US"/>
           </a:p>
@@ -1183,7 +1183,7 @@
           <a:p>
             <a:fld id="{E8FD0B7A-F5DD-4F40-B4CB-3B2C354B893A}" type="datetimeFigureOut">
               <a:rPr lang="en-US" smtClean="0"/>
-              <a:t>8/5/2025</a:t>
+              <a:t>8/14/2025</a:t>
             </a:fld>
             <a:endParaRPr lang="en-US"/>
           </a:p>
@@ -1516,7 +1516,7 @@
           <a:p>
             <a:fld id="{E8FD0B7A-F5DD-4F40-B4CB-3B2C354B893A}" type="datetimeFigureOut">
               <a:rPr lang="en-US" smtClean="0"/>
-              <a:t>8/5/2025</a:t>
+              <a:t>8/14/2025</a:t>
             </a:fld>
             <a:endParaRPr lang="en-US"/>
           </a:p>
@@ -1636,7 +1636,7 @@
           <a:p>
             <a:fld id="{E8FD0B7A-F5DD-4F40-B4CB-3B2C354B893A}" type="datetimeFigureOut">
               <a:rPr lang="en-US" smtClean="0"/>
-              <a:t>8/5/2025</a:t>
+              <a:t>8/14/2025</a:t>
             </a:fld>
             <a:endParaRPr lang="en-US"/>
           </a:p>
@@ -1732,7 +1732,7 @@
           <a:p>
             <a:fld id="{E8FD0B7A-F5DD-4F40-B4CB-3B2C354B893A}" type="datetimeFigureOut">
               <a:rPr lang="en-US" smtClean="0"/>
-              <a:t>8/5/2025</a:t>
+              <a:t>8/14/2025</a:t>
             </a:fld>
             <a:endParaRPr lang="en-US"/>
           </a:p>
@@ -1964,7 +1964,7 @@
           <a:p>
             <a:fld id="{E8FD0B7A-F5DD-4F40-B4CB-3B2C354B893A}" type="datetimeFigureOut">
               <a:rPr lang="en-US" smtClean="0"/>
-              <a:t>8/5/2025</a:t>
+              <a:t>8/14/2025</a:t>
             </a:fld>
             <a:endParaRPr lang="en-US"/>
           </a:p>
@@ -2164,7 +2164,7 @@
           <a:p>
             <a:fld id="{E8FD0B7A-F5DD-4F40-B4CB-3B2C354B893A}" type="datetimeFigureOut">
               <a:rPr lang="en-US" smtClean="0"/>
-              <a:t>8/5/2025</a:t>
+              <a:t>8/14/2025</a:t>
             </a:fld>
             <a:endParaRPr lang="en-US"/>
           </a:p>
@@ -2371,7 +2371,7 @@
           <a:p>
             <a:fld id="{E8FD0B7A-F5DD-4F40-B4CB-3B2C354B893A}" type="datetimeFigureOut">
               <a:rPr lang="en-US" smtClean="0"/>
-              <a:t>8/5/2025</a:t>
+              <a:t>8/14/2025</a:t>
             </a:fld>
             <a:endParaRPr lang="en-US"/>
           </a:p>
@@ -3902,46 +3902,46 @@
         </p:nvSpPr>
         <p:spPr>
           <a:xfrm>
-            <a:off x="2153297" y="2241002"/>
-            <a:ext cx="5973352" cy="325539"/>
-          </a:xfrm>
-          <a:prstGeom prst="rect">
-            <a:avLst/>
-          </a:prstGeom>
-          <a:noFill/>
-        </p:spPr>
-        <p:style>
-          <a:lnRef idx="2">
-            <a:srgbClr val="000000">
-              <a:alpha val="0"/>
-            </a:srgbClr>
-          </a:lnRef>
-          <a:fillRef idx="1">
-            <a:schemeClr val="accent1"/>
-          </a:fillRef>
-          <a:effectRef idx="0">
-            <a:schemeClr val="accent1"/>
-          </a:effectRef>
-          <a:fontRef idx="minor">
-            <a:schemeClr val="lt1"/>
-          </a:fontRef>
-        </p:style>
-        <p:txBody>
-          <a:bodyPr wrap="none" lIns="0" tIns="0" rtlCol="0" anchor="ctr">
-            <a:spAutoFit/>
-          </a:bodyPr>
-          <a:lstStyle>
-            <a:defPPr/>
-          </a:lstStyle>
-          <a:p>
-            <a:r>
-              <a:rPr lang="en-US" sz="2460">
+            <a:off x="2153297" y="2191406"/>
+            <a:ext cx="6071790" cy="424732"/>
+          </a:xfrm>
+          <a:prstGeom prst="rect">
+            <a:avLst/>
+          </a:prstGeom>
+          <a:noFill/>
+        </p:spPr>
+        <p:style>
+          <a:lnRef idx="2">
+            <a:srgbClr val="000000">
+              <a:alpha val="0"/>
+            </a:srgbClr>
+          </a:lnRef>
+          <a:fillRef idx="1">
+            <a:schemeClr val="accent1"/>
+          </a:fillRef>
+          <a:effectRef idx="0">
+            <a:schemeClr val="accent1"/>
+          </a:effectRef>
+          <a:fontRef idx="minor">
+            <a:schemeClr val="lt1"/>
+          </a:fontRef>
+        </p:style>
+        <p:txBody>
+          <a:bodyPr wrap="none" lIns="0" tIns="0" rtlCol="0" anchor="ctr">
+            <a:spAutoFit/>
+          </a:bodyPr>
+          <a:lstStyle>
+            <a:defPPr/>
+          </a:lstStyle>
+          <a:p>
+            <a:r>
+              <a:rPr lang="en-US" sz="2460" dirty="0">
                 <a:solidFill>
                   <a:srgbClr val="000000"/>
                 </a:solidFill>
                 <a:latin typeface="Calibri"/>
               </a:rPr>
-              <a:t>The CS50 IDE is a cloud-based machine running</a:t>
+              <a:t>The Sandbox is a cloud-based machine running</a:t>
             </a:r>
           </a:p>
         </p:txBody>

</xml_diff>